<commit_message>
Slide: fix subject-verb agreement, and drop the untested claim
Finding now reads 'and it holds at matched arousal', since the plural subject
needs the pronoun.

Step 2 header changes from LEFT UNTESTED to THE CONFOUND. Claiming something has
not been tested is an unfalsifiable negative about the whole literature and one
overlooked paper makes it look careless. The column body was already purely
descriptive about what MUStARD's design entails, so only the header needed to go.

Co-Authored-By: Claude Opus 4.8 <noreply@anthropic.com>
</commit_message>
<xml_diff>
--- a/docs/advisory_slide.pptx
+++ b/docs/advisory_slide.pptx
@@ -1235,7 +1235,7 @@
                 <a:ea typeface="Calibri" pitchFamily="34" charset="-122"/>
                 <a:cs typeface="Calibri" pitchFamily="34" charset="-120"/>
               </a:rPr>
-              <a:t>LEFT UNTESTED</a:t>
+              <a:t>THE CONFOUND</a:t>
             </a:r>
             <a:endParaRPr lang="en-US" sz="950" dirty="0"/>
           </a:p>
@@ -3758,7 +3758,7 @@
                 <a:ea typeface="Calibri" pitchFamily="34" charset="-122"/>
                 <a:cs typeface="Calibri" pitchFamily="34" charset="-120"/>
               </a:rPr>
-              <a:t>Continuous representations preserve pragmatic stance, and holds at matched arousal and on new speakers the probe never trained on, and within each word, where WavLM reaches 0.659 against 0.534 for text. The discrete tokens consumed by deployed systems sit barely above chance.</a:t>
+              <a:t>Continuous representations preserve pragmatic stance, and it holds at matched arousal and on new speakers the probe never trained on, and within each word, where WavLM reaches 0.659 against 0.534 for text. The discrete tokens consumed by deployed systems sit barely above chance.</a:t>
             </a:r>
             <a:endParaRPr lang="en-US" sz="1150" dirty="0"/>
           </a:p>

</xml_diff>

<commit_message>
Slide: add controls block, and drop the last absence claim
Extends the design-move card to align with the boxes opposite and fills the empty
space with the three controls an advisory group asks about first, arousal matched,
speaker held out, and non-independence. These were previously only in the notes.

Step 3's fourth mapping changes from 'no tokeniser tested' to 'continuous only',
which states what Lin et al. compared rather than what was absent.

Co-Authored-By: Claude Opus 4.8 <noreply@anthropic.com>
</commit_message>
<xml_diff>
--- a/docs/advisory_slide.pptx
+++ b/docs/advisory_slide.pptx
@@ -1694,7 +1694,7 @@
                 <a:ea typeface="Calibri" pitchFamily="34" charset="-122"/>
                 <a:cs typeface="Calibri" pitchFamily="34" charset="-120"/>
               </a:rPr>
-              <a:t>no tokeniser tested</a:t>
+              <a:t>continuous only</a:t>
             </a:r>
             <a:pPr indent="0" marL="0">
               <a:lnSpc>
@@ -1743,11 +1743,11 @@
         <p:spPr>
           <a:xfrm>
             <a:off x="457200" y="2578608"/>
-            <a:ext cx="3703320" cy="2724912"/>
+            <a:ext cx="3703320" cy="3310128"/>
           </a:xfrm>
           <a:prstGeom prst="roundRect">
             <a:avLst>
-              <a:gd name="adj" fmla="val 2013"/>
+              <a:gd name="adj" fmla="val 1657"/>
             </a:avLst>
           </a:prstGeom>
           <a:solidFill>
@@ -2371,7 +2371,202 @@
       </p:sp>
       <p:sp>
         <p:nvSpPr>
-          <p:cNvPr id="35" name="Text 33"/>
+          <p:cNvPr id="35" name="Shape 33"/>
+          <p:cNvSpPr/>
+          <p:nvPr/>
+        </p:nvSpPr>
+        <p:spPr>
+          <a:xfrm>
+            <a:off x="658368" y="5138928"/>
+            <a:ext cx="3300984" cy="0"/>
+          </a:xfrm>
+          <a:prstGeom prst="line">
+            <a:avLst/>
+          </a:prstGeom>
+          <a:noFill/>
+          <a:ln w="9525">
+            <a:solidFill>
+              <a:srgbClr val="DDE1E7"/>
+            </a:solidFill>
+            <a:prstDash val="solid"/>
+          </a:ln>
+        </p:spPr>
+      </p:sp>
+      <p:sp>
+        <p:nvSpPr>
+          <p:cNvPr id="36" name="Text 34"/>
+          <p:cNvSpPr/>
+          <p:nvPr/>
+        </p:nvSpPr>
+        <p:spPr>
+          <a:xfrm>
+            <a:off x="658368" y="5212080"/>
+            <a:ext cx="3300984" cy="182880"/>
+          </a:xfrm>
+          <a:prstGeom prst="rect">
+            <a:avLst/>
+          </a:prstGeom>
+          <a:noFill/>
+          <a:ln/>
+        </p:spPr>
+        <p:txBody>
+          <a:bodyPr wrap="square" lIns="0" tIns="0" rIns="0" bIns="0" rtlCol="0" anchor="ctr"/>
+          <a:lstStyle/>
+          <a:p>
+            <a:pPr indent="0" marL="0">
+              <a:buNone/>
+            </a:pPr>
+            <a:r>
+              <a:rPr lang="en-US" sz="900" b="1" spc="110" kern="0" dirty="0">
+                <a:solidFill>
+                  <a:srgbClr val="0F7A84"/>
+                </a:solidFill>
+                <a:latin typeface="Calibri" pitchFamily="34" charset="0"/>
+                <a:ea typeface="Calibri" pitchFamily="34" charset="-122"/>
+                <a:cs typeface="Calibri" pitchFamily="34" charset="-120"/>
+              </a:rPr>
+              <a:t>CONTROLS</a:t>
+            </a:r>
+            <a:endParaRPr lang="en-US" sz="900" dirty="0"/>
+          </a:p>
+        </p:txBody>
+      </p:sp>
+      <p:sp>
+        <p:nvSpPr>
+          <p:cNvPr id="37" name="Text 35"/>
+          <p:cNvSpPr/>
+          <p:nvPr/>
+        </p:nvSpPr>
+        <p:spPr>
+          <a:xfrm>
+            <a:off x="658368" y="5431536"/>
+            <a:ext cx="3300984" cy="420624"/>
+          </a:xfrm>
+          <a:prstGeom prst="rect">
+            <a:avLst/>
+          </a:prstGeom>
+          <a:noFill/>
+          <a:ln/>
+        </p:spPr>
+        <p:txBody>
+          <a:bodyPr wrap="square" lIns="0" tIns="0" rIns="0" bIns="0" rtlCol="0" anchor="ctr"/>
+          <a:lstStyle/>
+          <a:p>
+            <a:pPr indent="0" marL="0">
+              <a:lnSpc>
+                <a:spcPct val="106000"/>
+              </a:lnSpc>
+              <a:buNone/>
+            </a:pPr>
+            <a:r>
+              <a:rPr lang="en-US" sz="850" b="1" dirty="0">
+                <a:solidFill>
+                  <a:srgbClr val="131920"/>
+                </a:solidFill>
+                <a:latin typeface="Calibri" pitchFamily="34" charset="0"/>
+                <a:ea typeface="Calibri" pitchFamily="34" charset="-122"/>
+                <a:cs typeface="Calibri" pitchFamily="34" charset="-120"/>
+              </a:rPr>
+              <a:t>Arousal matched</a:t>
+            </a:r>
+            <a:pPr indent="0" marL="0">
+              <a:lnSpc>
+                <a:spcPct val="106000"/>
+              </a:lnSpc>
+              <a:buNone/>
+            </a:pPr>
+            <a:r>
+              <a:rPr lang="en-US" sz="850" dirty="0">
+                <a:solidFill>
+                  <a:srgbClr val="5C6773"/>
+                </a:solidFill>
+                <a:latin typeface="Calibri" pitchFamily="34" charset="0"/>
+                <a:ea typeface="Calibri" pitchFamily="34" charset="-122"/>
+                <a:cs typeface="Calibri" pitchFamily="34" charset="-120"/>
+              </a:rPr>
+              <a:t>, stance still decoded within each level.</a:t>
+            </a:r>
+            <a:endParaRPr lang="en-US" sz="850" dirty="0"/>
+          </a:p>
+          <a:p>
+            <a:pPr indent="0" marL="0">
+              <a:lnSpc>
+                <a:spcPct val="106000"/>
+              </a:lnSpc>
+              <a:buNone/>
+            </a:pPr>
+            <a:r>
+              <a:rPr lang="en-US" sz="850" b="1" dirty="0">
+                <a:solidFill>
+                  <a:srgbClr val="131920"/>
+                </a:solidFill>
+                <a:latin typeface="Calibri" pitchFamily="34" charset="0"/>
+                <a:ea typeface="Calibri" pitchFamily="34" charset="-122"/>
+                <a:cs typeface="Calibri" pitchFamily="34" charset="-120"/>
+              </a:rPr>
+              <a:t>Speaker held out</a:t>
+            </a:r>
+            <a:pPr indent="0" marL="0">
+              <a:lnSpc>
+                <a:spcPct val="106000"/>
+              </a:lnSpc>
+              <a:buNone/>
+            </a:pPr>
+            <a:r>
+              <a:rPr lang="en-US" sz="850" dirty="0">
+                <a:solidFill>
+                  <a:srgbClr val="5C6773"/>
+                </a:solidFill>
+                <a:latin typeface="Calibri" pitchFamily="34" charset="0"/>
+                <a:ea typeface="Calibri" pitchFamily="34" charset="-122"/>
+                <a:cs typeface="Calibri" pitchFamily="34" charset="-120"/>
+              </a:rPr>
+              <a:t>, WavLM 0.573 to 0.530 by show.</a:t>
+            </a:r>
+            <a:endParaRPr lang="en-US" sz="850" dirty="0"/>
+          </a:p>
+          <a:p>
+            <a:pPr indent="0" marL="0">
+              <a:lnSpc>
+                <a:spcPct val="106000"/>
+              </a:lnSpc>
+              <a:buNone/>
+            </a:pPr>
+            <a:r>
+              <a:rPr lang="en-US" sz="850" b="1" dirty="0">
+                <a:solidFill>
+                  <a:srgbClr val="131920"/>
+                </a:solidFill>
+                <a:latin typeface="Calibri" pitchFamily="34" charset="0"/>
+                <a:ea typeface="Calibri" pitchFamily="34" charset="-122"/>
+                <a:cs typeface="Calibri" pitchFamily="34" charset="-120"/>
+              </a:rPr>
+              <a:t>Non-independence</a:t>
+            </a:r>
+            <a:pPr indent="0" marL="0">
+              <a:lnSpc>
+                <a:spcPct val="106000"/>
+              </a:lnSpc>
+              <a:buNone/>
+            </a:pPr>
+            <a:r>
+              <a:rPr lang="en-US" sz="850" dirty="0">
+                <a:solidFill>
+                  <a:srgbClr val="5C6773"/>
+                </a:solidFill>
+                <a:latin typeface="Calibri" pitchFamily="34" charset="0"/>
+                <a:ea typeface="Calibri" pitchFamily="34" charset="-122"/>
+                <a:cs typeface="Calibri" pitchFamily="34" charset="-120"/>
+              </a:rPr>
+              <a:t>, episode folds, bootstrap, 200 permutations.</a:t>
+            </a:r>
+            <a:endParaRPr lang="en-US" sz="850" dirty="0"/>
+          </a:p>
+        </p:txBody>
+      </p:sp>
+      <p:sp>
+        <p:nvSpPr>
+          <p:cNvPr id="38" name="Text 36"/>
           <p:cNvSpPr/>
           <p:nvPr/>
         </p:nvSpPr>
@@ -2410,7 +2605,7 @@
       </p:sp>
       <p:sp>
         <p:nvSpPr>
-          <p:cNvPr id="36" name="Shape 34"/>
+          <p:cNvPr id="39" name="Shape 37"/>
           <p:cNvSpPr/>
           <p:nvPr/>
         </p:nvSpPr>
@@ -2433,7 +2628,7 @@
       </p:sp>
       <p:sp>
         <p:nvSpPr>
-          <p:cNvPr id="37" name="Text 35"/>
+          <p:cNvPr id="40" name="Text 38"/>
           <p:cNvSpPr/>
           <p:nvPr/>
         </p:nvSpPr>
@@ -2472,7 +2667,7 @@
       </p:sp>
       <p:sp>
         <p:nvSpPr>
-          <p:cNvPr id="38" name="Shape 36"/>
+          <p:cNvPr id="41" name="Shape 39"/>
           <p:cNvSpPr/>
           <p:nvPr/>
         </p:nvSpPr>
@@ -2495,7 +2690,7 @@
       </p:sp>
       <p:sp>
         <p:nvSpPr>
-          <p:cNvPr id="39" name="Text 37"/>
+          <p:cNvPr id="42" name="Text 40"/>
           <p:cNvSpPr/>
           <p:nvPr/>
         </p:nvSpPr>
@@ -2534,7 +2729,7 @@
       </p:sp>
       <p:sp>
         <p:nvSpPr>
-          <p:cNvPr id="40" name="Shape 38"/>
+          <p:cNvPr id="43" name="Shape 41"/>
           <p:cNvSpPr/>
           <p:nvPr/>
         </p:nvSpPr>
@@ -2557,7 +2752,7 @@
       </p:sp>
       <p:sp>
         <p:nvSpPr>
-          <p:cNvPr id="41" name="Text 39"/>
+          <p:cNvPr id="44" name="Text 42"/>
           <p:cNvSpPr/>
           <p:nvPr/>
         </p:nvSpPr>
@@ -2596,7 +2791,7 @@
       </p:sp>
       <p:sp>
         <p:nvSpPr>
-          <p:cNvPr id="42" name="Shape 40"/>
+          <p:cNvPr id="45" name="Shape 43"/>
           <p:cNvSpPr/>
           <p:nvPr/>
         </p:nvSpPr>
@@ -2619,7 +2814,7 @@
       </p:sp>
       <p:sp>
         <p:nvSpPr>
-          <p:cNvPr id="43" name="Text 41"/>
+          <p:cNvPr id="46" name="Text 44"/>
           <p:cNvSpPr/>
           <p:nvPr/>
         </p:nvSpPr>
@@ -2658,7 +2853,7 @@
       </p:sp>
       <p:sp>
         <p:nvSpPr>
-          <p:cNvPr id="44" name="Shape 42"/>
+          <p:cNvPr id="47" name="Shape 45"/>
           <p:cNvSpPr/>
           <p:nvPr/>
         </p:nvSpPr>
@@ -2681,7 +2876,7 @@
       </p:sp>
       <p:sp>
         <p:nvSpPr>
-          <p:cNvPr id="45" name="Text 43"/>
+          <p:cNvPr id="48" name="Text 46"/>
           <p:cNvSpPr/>
           <p:nvPr/>
         </p:nvSpPr>
@@ -2720,7 +2915,7 @@
       </p:sp>
       <p:sp>
         <p:nvSpPr>
-          <p:cNvPr id="46" name="Text 44"/>
+          <p:cNvPr id="49" name="Text 47"/>
           <p:cNvSpPr/>
           <p:nvPr/>
         </p:nvSpPr>
@@ -2759,7 +2954,7 @@
       </p:sp>
       <p:sp>
         <p:nvSpPr>
-          <p:cNvPr id="47" name="Shape 45"/>
+          <p:cNvPr id="50" name="Shape 48"/>
           <p:cNvSpPr/>
           <p:nvPr/>
         </p:nvSpPr>
@@ -2784,7 +2979,7 @@
       </p:sp>
       <p:sp>
         <p:nvSpPr>
-          <p:cNvPr id="48" name="Text 46"/>
+          <p:cNvPr id="51" name="Text 49"/>
           <p:cNvSpPr/>
           <p:nvPr/>
         </p:nvSpPr>
@@ -2823,7 +3018,7 @@
       </p:sp>
       <p:sp>
         <p:nvSpPr>
-          <p:cNvPr id="49" name="Text 47"/>
+          <p:cNvPr id="52" name="Text 50"/>
           <p:cNvSpPr/>
           <p:nvPr/>
         </p:nvSpPr>
@@ -2862,7 +3057,7 @@
       </p:sp>
       <p:sp>
         <p:nvSpPr>
-          <p:cNvPr id="50" name="Shape 48"/>
+          <p:cNvPr id="53" name="Shape 51"/>
           <p:cNvSpPr/>
           <p:nvPr/>
         </p:nvSpPr>
@@ -2887,7 +3082,7 @@
       </p:sp>
       <p:sp>
         <p:nvSpPr>
-          <p:cNvPr id="51" name="Text 49"/>
+          <p:cNvPr id="54" name="Text 52"/>
           <p:cNvSpPr/>
           <p:nvPr/>
         </p:nvSpPr>
@@ -2926,7 +3121,7 @@
       </p:sp>
       <p:sp>
         <p:nvSpPr>
-          <p:cNvPr id="52" name="Text 50"/>
+          <p:cNvPr id="55" name="Text 53"/>
           <p:cNvSpPr/>
           <p:nvPr/>
         </p:nvSpPr>
@@ -2965,7 +3160,7 @@
       </p:sp>
       <p:sp>
         <p:nvSpPr>
-          <p:cNvPr id="53" name="Shape 51"/>
+          <p:cNvPr id="56" name="Shape 54"/>
           <p:cNvSpPr/>
           <p:nvPr/>
         </p:nvSpPr>
@@ -2990,7 +3185,7 @@
       </p:sp>
       <p:sp>
         <p:nvSpPr>
-          <p:cNvPr id="54" name="Text 52"/>
+          <p:cNvPr id="57" name="Text 55"/>
           <p:cNvSpPr/>
           <p:nvPr/>
         </p:nvSpPr>
@@ -3029,7 +3224,7 @@
       </p:sp>
       <p:sp>
         <p:nvSpPr>
-          <p:cNvPr id="55" name="Text 53"/>
+          <p:cNvPr id="58" name="Text 56"/>
           <p:cNvSpPr/>
           <p:nvPr/>
         </p:nvSpPr>
@@ -3068,7 +3263,7 @@
       </p:sp>
       <p:sp>
         <p:nvSpPr>
-          <p:cNvPr id="56" name="Shape 54"/>
+          <p:cNvPr id="59" name="Shape 57"/>
           <p:cNvSpPr/>
           <p:nvPr/>
         </p:nvSpPr>
@@ -3093,7 +3288,7 @@
       </p:sp>
       <p:sp>
         <p:nvSpPr>
-          <p:cNvPr id="57" name="Text 55"/>
+          <p:cNvPr id="60" name="Text 58"/>
           <p:cNvSpPr/>
           <p:nvPr/>
         </p:nvSpPr>
@@ -3132,7 +3327,7 @@
       </p:sp>
       <p:sp>
         <p:nvSpPr>
-          <p:cNvPr id="58" name="Text 56"/>
+          <p:cNvPr id="61" name="Text 59"/>
           <p:cNvSpPr/>
           <p:nvPr/>
         </p:nvSpPr>
@@ -3171,7 +3366,7 @@
       </p:sp>
       <p:sp>
         <p:nvSpPr>
-          <p:cNvPr id="59" name="Shape 57"/>
+          <p:cNvPr id="62" name="Shape 60"/>
           <p:cNvSpPr/>
           <p:nvPr/>
         </p:nvSpPr>
@@ -3196,7 +3391,7 @@
       </p:sp>
       <p:sp>
         <p:nvSpPr>
-          <p:cNvPr id="60" name="Text 58"/>
+          <p:cNvPr id="63" name="Text 61"/>
           <p:cNvSpPr/>
           <p:nvPr/>
         </p:nvSpPr>
@@ -3235,7 +3430,7 @@
       </p:sp>
       <p:sp>
         <p:nvSpPr>
-          <p:cNvPr id="61" name="Text 59"/>
+          <p:cNvPr id="64" name="Text 62"/>
           <p:cNvSpPr/>
           <p:nvPr/>
         </p:nvSpPr>
@@ -3274,7 +3469,7 @@
       </p:sp>
       <p:sp>
         <p:nvSpPr>
-          <p:cNvPr id="62" name="Shape 60"/>
+          <p:cNvPr id="65" name="Shape 63"/>
           <p:cNvSpPr/>
           <p:nvPr/>
         </p:nvSpPr>
@@ -3299,7 +3494,7 @@
       </p:sp>
       <p:sp>
         <p:nvSpPr>
-          <p:cNvPr id="63" name="Text 61"/>
+          <p:cNvPr id="66" name="Text 64"/>
           <p:cNvSpPr/>
           <p:nvPr/>
         </p:nvSpPr>
@@ -3338,7 +3533,7 @@
       </p:sp>
       <p:sp>
         <p:nvSpPr>
-          <p:cNvPr id="64" name="Shape 62"/>
+          <p:cNvPr id="67" name="Shape 65"/>
           <p:cNvSpPr/>
           <p:nvPr/>
         </p:nvSpPr>
@@ -3365,7 +3560,7 @@
       </p:sp>
       <p:sp>
         <p:nvSpPr>
-          <p:cNvPr id="65" name="Shape 63"/>
+          <p:cNvPr id="68" name="Shape 66"/>
           <p:cNvSpPr/>
           <p:nvPr/>
         </p:nvSpPr>
@@ -3392,7 +3587,7 @@
       </p:sp>
       <p:sp>
         <p:nvSpPr>
-          <p:cNvPr id="66" name="Text 64"/>
+          <p:cNvPr id="69" name="Text 67"/>
           <p:cNvSpPr/>
           <p:nvPr/>
         </p:nvSpPr>
@@ -3451,7 +3646,7 @@
       </p:sp>
       <p:sp>
         <p:nvSpPr>
-          <p:cNvPr id="67" name="Text 65"/>
+          <p:cNvPr id="70" name="Text 68"/>
           <p:cNvSpPr/>
           <p:nvPr/>
         </p:nvSpPr>
@@ -3680,7 +3875,7 @@
       </p:sp>
       <p:sp>
         <p:nvSpPr>
-          <p:cNvPr id="68" name="Shape 66"/>
+          <p:cNvPr id="71" name="Shape 69"/>
           <p:cNvSpPr/>
           <p:nvPr/>
         </p:nvSpPr>
@@ -3707,7 +3902,7 @@
       </p:sp>
       <p:sp>
         <p:nvSpPr>
-          <p:cNvPr id="69" name="Text 67"/>
+          <p:cNvPr id="72" name="Text 70"/>
           <p:cNvSpPr/>
           <p:nvPr/>
         </p:nvSpPr>

</xml_diff>

<commit_message>
Slide: replace "speaker held out" with plain wording
"Held out" is machine-learning jargon and "by show" carried the whole mechanism
in two unexplained words. Caro had to ask what the line meant, which is a reliable
sign an advisory group would too. The control now reads "Unseen speakers, train
and test never share a show, 0.573 to 0.530", which names the mechanism in plain
English, still fits one line, and matches the "new speakers" wording already used
in the Finding.

Speaker notes expanded to explain why the stricter grouping is needed, namely that
episode-grouped folds still let one host appear on both sides, and that WavLM
encodes speaker identity strongly enough for that to matter.

Co-Authored-By: Claude Opus 4.8 <noreply@anthropic.com>
</commit_message>
<xml_diff>
--- a/docs/advisory_slide.pptx
+++ b/docs/advisory_slide.pptx
@@ -514,7 +514,7 @@
 Macro-F1 has no fixed chance value. A majority-class predictor scores only 0.196 here because macro-F1 gives zero to the two classes it never predicts, but our probe uses balanced class weights and spreads predictions across all three, so that is not its no-skill counterpart. The reference on the chart is the empirical permutation null, the same probe refit on shuffled labels, which sits near 0.33. Uniform and prior-matched random guessing give 0.322 and 0.333, agreeing closely.
 ROBUSTNESS
 Matched arousal. Stance is still decoded within each arousal level separately, so the probe is not simply reading loudness.
-Speaker held out. Grouping folds by show rather than episode moves WavLM only from 0.573 to 0.530, so it is not riding speaker identity.
+Unseen speakers. Folds are grouped by episode in the main analysis, but two episodes of one show share a host, so speaker identity could still leak. Grouping by show instead puts an entire show and its host either in training or in testing, never both, which forces the probe onto voices it has never heard. WavLM moves only from 0.573 to 0.530, so it is reading delivery rather than recognising who is speaking.
 Non-independence. All scores are out of fold under GroupKFold by episode, with episode-cluster bootstrap intervals and 200-permutation tests. Every representation beats chance at p at most 0.01.
 WHERE THE CONTRAST LIVES
 WavLM peaks at layer 20 of 24 and falls away above it, consistent with upper layers shedding paralinguistics. Whisper plateaus across its top third. Inside Mimi, what little survives sits in codebook 0, the WavLM-distilled stream, at 0.402. The seven acoustic refinement codebooks are at or near chance and five of them are not significant. Chapter 2 predicted the opposite, so this is reported as a corrected expectation.
@@ -2504,7 +2504,7 @@
                 <a:ea typeface="Calibri" pitchFamily="34" charset="-122"/>
                 <a:cs typeface="Calibri" pitchFamily="34" charset="-120"/>
               </a:rPr>
-              <a:t>Speaker held out</a:t>
+              <a:t>Unseen speakers</a:t>
             </a:r>
             <a:pPr indent="0" marL="0">
               <a:lnSpc>
@@ -2521,7 +2521,7 @@
                 <a:ea typeface="Calibri" pitchFamily="34" charset="-122"/>
                 <a:cs typeface="Calibri" pitchFamily="34" charset="-120"/>
               </a:rPr>
-              <a:t>, WavLM 0.573 to 0.530 by show.</a:t>
+              <a:t>, train and test never share a show, 0.573 to 0.530.</a:t>
             </a:r>
             <a:endParaRPr lang="en-US" sz="850" dirty="0"/>
           </a:p>

</xml_diff>

<commit_message>
Slide: plainer third control, and rewrite the Finding
"Non-independence" named a statistical concept rather than saying what was done
about it. Now "Clustered data, folds and bootstrap by episode, 200 permutations",
which states the problem and the two things that address it.

The Finding was duplicating the controls block added two commits ago, listing
matched arousal and unseen speakers that the card already covers, which is why it
sprawled across three clauses joined by "and". Freed of that it states the result
in three short sentences with a survives-and-does-not-survive parallel, keeps the
lexical control figure, and hedges honestly with "most of it" since Mimi remains
significantly above chance.

Co-Authored-By: Claude Opus 4.8 <noreply@anthropic.com>
</commit_message>
<xml_diff>
--- a/docs/advisory_slide.pptx
+++ b/docs/advisory_slide.pptx
@@ -2440,7 +2440,7 @@
         <p:spPr>
           <a:xfrm>
             <a:off x="658368" y="5431536"/>
-            <a:ext cx="3300984" cy="420624"/>
+            <a:ext cx="3300984" cy="475488"/>
           </a:xfrm>
           <a:prstGeom prst="rect">
             <a:avLst/>
@@ -2541,7 +2541,7 @@
                 <a:ea typeface="Calibri" pitchFamily="34" charset="-122"/>
                 <a:cs typeface="Calibri" pitchFamily="34" charset="-120"/>
               </a:rPr>
-              <a:t>Non-independence</a:t>
+              <a:t>Clustered data</a:t>
             </a:r>
             <a:pPr indent="0" marL="0">
               <a:lnSpc>
@@ -2558,7 +2558,7 @@
                 <a:ea typeface="Calibri" pitchFamily="34" charset="-122"/>
                 <a:cs typeface="Calibri" pitchFamily="34" charset="-120"/>
               </a:rPr>
-              <a:t>, episode folds, bootstrap, 200 permutations.</a:t>
+              <a:t>, folds and bootstrap by episode, 200 permutations.</a:t>
             </a:r>
             <a:endParaRPr lang="en-US" sz="850" dirty="0"/>
           </a:p>
@@ -3953,7 +3953,7 @@
                 <a:ea typeface="Calibri" pitchFamily="34" charset="-122"/>
                 <a:cs typeface="Calibri" pitchFamily="34" charset="-120"/>
               </a:rPr>
-              <a:t>Continuous representations preserve pragmatic stance, and it holds at matched arousal and on new speakers the probe never trained on, and within each word, where WavLM reaches 0.659 against 0.534 for text. The discrete tokens consumed by deployed systems sit barely above chance.</a:t>
+              <a:t>Pragmatic stance survives in continuous representations, and it survives the lexical control, where WavLM reaches 0.659 against 0.534 for text. Most of it does not survive discretisation. The tokens deployed systems consume sit barely above chance.</a:t>
             </a:r>
             <a:endParaRPr lang="en-US" sz="1150" dirty="0"/>
           </a:p>

</xml_diff>